<commit_message>
Add day 6 materials
</commit_message>
<xml_diff>
--- a/заняття_5/презентація/basic_regression.pptx
+++ b/заняття_5/презентація/basic_regression.pptx
@@ -10437,7 +10437,7 @@
         <p:spPr>
           <a:xfrm>
             <a:off x="5285232" y="3995928"/>
-            <a:ext cx="2916936" cy="246888"/>
+            <a:ext cx="2916936" cy="310896"/>
           </a:xfrm>
           <a:prstGeom prst="rect">
             <a:avLst/>
@@ -10447,7 +10447,7 @@
         </p:spPr>
         <p:txBody>
           <a:bodyPr wrap="square" lIns="0" tIns="0" rIns="0" bIns="0" rtlCol="0" anchor="t">
-            <a:normAutofit fontScale="85000" lnSpcReduction="20000"/>
+            <a:normAutofit fontScale="92500" lnSpcReduction="10000"/>
           </a:bodyPr>
           <a:lstStyle/>
           <a:p>
@@ -10507,10 +10507,10 @@
                 <a:ea typeface="Calibri" pitchFamily="34" charset="-122"/>
                 <a:cs typeface="Calibri" pitchFamily="34" charset="-120"/>
               </a:rPr>
-              <a:t> такі самі, </a:t>
-            </a:r>
-            <a:r>
-              <a:rPr lang="en-US" sz="1170" dirty="0" err="1">
+              <a:t> такі самі, як </a:t>
+            </a:r>
+            <a:r>
+              <a:rPr lang="uk-UA" sz="1170" dirty="0">
                 <a:solidFill>
                   <a:srgbClr val="E0E8FF"/>
                 </a:solidFill>
@@ -10518,7 +10518,7 @@
                 <a:ea typeface="Calibri" pitchFamily="34" charset="-122"/>
                 <a:cs typeface="Calibri" pitchFamily="34" charset="-120"/>
               </a:rPr>
-              <a:t>як</a:t>
+              <a:t>і </a:t>
             </a:r>
             <a:r>
               <a:rPr lang="en-US" sz="1170" dirty="0">
@@ -10529,40 +10529,7 @@
                 <a:ea typeface="Calibri" pitchFamily="34" charset="-122"/>
                 <a:cs typeface="Calibri" pitchFamily="34" charset="-120"/>
               </a:rPr>
-              <a:t> </a:t>
-            </a:r>
-            <a:r>
-              <a:rPr lang="uk-UA" sz="1170" dirty="0">
-                <a:solidFill>
-                  <a:srgbClr val="E0E8FF"/>
-                </a:solidFill>
-                <a:latin typeface="Calibri" pitchFamily="34" charset="0"/>
-                <a:ea typeface="Calibri" pitchFamily="34" charset="-122"/>
-                <a:cs typeface="Calibri" pitchFamily="34" charset="-120"/>
-              </a:rPr>
-              <a:t>і </a:t>
-            </a:r>
-            <a:r>
-              <a:rPr lang="en-US" sz="1170" dirty="0" err="1">
-                <a:solidFill>
-                  <a:srgbClr val="E0E8FF"/>
-                </a:solidFill>
-                <a:latin typeface="Calibri" pitchFamily="34" charset="0"/>
-                <a:ea typeface="Calibri" pitchFamily="34" charset="-122"/>
-                <a:cs typeface="Calibri" pitchFamily="34" charset="-120"/>
-              </a:rPr>
-              <a:t>у</a:t>
-            </a:r>
-            <a:r>
-              <a:rPr lang="en-US" sz="1170" dirty="0">
-                <a:solidFill>
-                  <a:srgbClr val="E0E8FF"/>
-                </a:solidFill>
-                <a:latin typeface="Calibri" pitchFamily="34" charset="0"/>
-                <a:ea typeface="Calibri" pitchFamily="34" charset="-122"/>
-                <a:cs typeface="Calibri" pitchFamily="34" charset="-120"/>
-              </a:rPr>
-              <a:t> `y`.</a:t>
+              <a:t>у `y`.</a:t>
             </a:r>
             <a:endParaRPr lang="en-US" sz="1170" dirty="0"/>
           </a:p>
@@ -16236,7 +16203,23 @@
                   <a:srgbClr val="8892B0"/>
                 </a:solidFill>
               </a:rPr>
-              <a:t>Для першої моделі дивимося не одну метрику, а картину: таблиця прогнозів + графік + MAE/RMSE/R2.</a:t>
+              <a:t>Дивимося не одну метрику, а </a:t>
+            </a:r>
+            <a:r>
+              <a:rPr lang="uk-UA" sz="1200" dirty="0">
+                <a:solidFill>
+                  <a:srgbClr val="8892B0"/>
+                </a:solidFill>
+              </a:rPr>
+              <a:t>на повну </a:t>
+            </a:r>
+            <a:r>
+              <a:rPr lang="en-US" sz="1200" dirty="0">
+                <a:solidFill>
+                  <a:srgbClr val="8892B0"/>
+                </a:solidFill>
+              </a:rPr>
+              <a:t>картину: таблиця прогнозів + графік + MAE/RMSE/R2.</a:t>
             </a:r>
             <a:endParaRPr lang="en-US" sz="1200" dirty="0"/>
           </a:p>

</xml_diff>